<commit_message>
Add 'generated for client' message
</commit_message>
<xml_diff>
--- a/src/report_generator/presets/templates/hygiene-report.pptx
+++ b/src/report_generator/presets/templates/hygiene-report.pptx
@@ -207,7 +207,7 @@
             <c:invertIfNegative val="0"/>
             <c:bubble3D val="0"/>
             <c:explosion val="6"/>
-            <c:extLst xmlns:w="http://schemas.openxmlformats.org/wordprocessingml/2006/main" xmlns:w15="http://schemas.microsoft.com/office/word/2012/wordml" xmlns:w14="http://schemas.microsoft.com/office/word/2010/wordml" xmlns:m="http://schemas.openxmlformats.org/officeDocument/2006/math" xmlns:wp="http://schemas.openxmlformats.org/drawingml/2006/wordprocessingDrawing" xmlns:wp14="http://schemas.microsoft.com/office/word/2010/wordprocessingDrawing" xmlns:mc="http://schemas.openxmlformats.org/markup-compatibility/2006" xmlns:sl="http://schemas.openxmlformats.org/schemaLibrary/2006/main" xmlns:wne="http://schemas.microsoft.com/office/word/2006/wordml" xmlns:cdr="http://schemas.openxmlformats.org/drawingml/2006/chartDrawing" xmlns:c14="http://schemas.microsoft.com/office/drawing/2007/8/2/chart" xmlns:dgm="http://schemas.openxmlformats.org/drawingml/2006/diagram" xmlns:pic="http://schemas.openxmlformats.org/drawingml/2006/picture" xmlns:xdr="http://schemas.openxmlformats.org/drawingml/2006/spreadsheetDrawing" xmlns:dsp="http://schemas.microsoft.com/office/drawing/2008/diagram" xmlns:xvml="urn:schemas-microsoft-com:office:excel" xmlns:o="urn:schemas-microsoft-com:office:office" xmlns:v="urn:schemas-microsoft-com:vml" xmlns:w10="urn:schemas-microsoft-com:office:word" xmlns:pvml="urn:schemas-microsoft-com:office:powerpoint" xmlns:cppr="http://schemas.microsoft.com/office/2006/coverPageProps" xmlns:odx="http://opendope.org/xpaths" xmlns:odc="http://opendope.org/conditions" xmlns:odq="http://opendope.org/questions" xmlns:oda="http://opendope.org/answers" xmlns:odi="http://opendope.org/components" xmlns:odgm="http://opendope.org/SmartArt/DataHierarchy" xmlns:b="http://schemas.openxmlformats.org/officeDocument/2006/bibliography" xmlns:wps="http://schemas.microsoft.com/office/word/2010/wordprocessingShape" xmlns:w16se="http://schemas.microsoft.com/office/word/2015/wordml/symex" xmlns:w16cid="http://schemas.microsoft.com/office/word/2016/wordml/cid" xmlns:wetp="http://schemas.microsoft.com/office/webextensions/taskpanes/2010/11" xmlns:we="http://schemas.microsoft.com/office/webextensions/webextension/2010/11" xmlns:comp="http://schemas.openxmlformats.org/drawingml/2006/compatibility" xmlns:lc="http://schemas.openxmlformats.org/drawingml/2006/lockedCanvas">
+            <c:extLst xmlns:lc="http://schemas.openxmlformats.org/drawingml/2006/lockedCanvas" xmlns:comp="http://schemas.openxmlformats.org/drawingml/2006/compatibility" xmlns:we="http://schemas.microsoft.com/office/webextensions/webextension/2010/11" xmlns:wetp="http://schemas.microsoft.com/office/webextensions/taskpanes/2010/11" xmlns:w16cid="http://schemas.microsoft.com/office/word/2016/wordml/cid" xmlns:w16se="http://schemas.microsoft.com/office/word/2015/wordml/symex" xmlns:wps="http://schemas.microsoft.com/office/word/2010/wordprocessingShape" xmlns:b="http://schemas.openxmlformats.org/officeDocument/2006/bibliography" xmlns:odgm="http://opendope.org/SmartArt/DataHierarchy" xmlns:odi="http://opendope.org/components" xmlns:oda="http://opendope.org/answers" xmlns:odq="http://opendope.org/questions" xmlns:odc="http://opendope.org/conditions" xmlns:odx="http://opendope.org/xpaths" xmlns:cppr="http://schemas.microsoft.com/office/2006/coverPageProps" xmlns:pvml="urn:schemas-microsoft-com:office:powerpoint" xmlns:w10="urn:schemas-microsoft-com:office:word" xmlns:v="urn:schemas-microsoft-com:vml" xmlns:o="urn:schemas-microsoft-com:office:office" xmlns:xvml="urn:schemas-microsoft-com:office:excel" xmlns:dsp="http://schemas.microsoft.com/office/drawing/2008/diagram" xmlns:xdr="http://schemas.openxmlformats.org/drawingml/2006/spreadsheetDrawing" xmlns:pic="http://schemas.openxmlformats.org/drawingml/2006/picture" xmlns:dgm="http://schemas.openxmlformats.org/drawingml/2006/diagram" xmlns:c14="http://schemas.microsoft.com/office/drawing/2007/8/2/chart" xmlns:cdr="http://schemas.openxmlformats.org/drawingml/2006/chartDrawing" xmlns:wne="http://schemas.microsoft.com/office/word/2006/wordml" xmlns:sl="http://schemas.openxmlformats.org/schemaLibrary/2006/main" xmlns:mc="http://schemas.openxmlformats.org/markup-compatibility/2006" xmlns:wp14="http://schemas.microsoft.com/office/word/2010/wordprocessingDrawing" xmlns:wp="http://schemas.openxmlformats.org/drawingml/2006/wordprocessingDrawing" xmlns:m="http://schemas.openxmlformats.org/officeDocument/2006/math" xmlns:w14="http://schemas.microsoft.com/office/word/2010/wordml" xmlns:w15="http://schemas.microsoft.com/office/word/2012/wordml" xmlns:w="http://schemas.openxmlformats.org/wordprocessingml/2006/main">
               <c:ext xmlns:c16="http://schemas.microsoft.com/office/drawing/2014/chart" uri="{C3380CC4-5D6E-409C-BE32-E72D297353CC}">
                 <c16:uniqueId val="{00000000-7C96-CF4F-94AD-E08A5CD6D25E}"/>
               </c:ext>
@@ -346,7 +346,7 @@
               </c:numCache>
             </c:numRef>
           </c:val>
-          <c:extLst xmlns:w="http://schemas.openxmlformats.org/wordprocessingml/2006/main" xmlns:w15="http://schemas.microsoft.com/office/word/2012/wordml" xmlns:w14="http://schemas.microsoft.com/office/word/2010/wordml" xmlns:m="http://schemas.openxmlformats.org/officeDocument/2006/math" xmlns:wp="http://schemas.openxmlformats.org/drawingml/2006/wordprocessingDrawing" xmlns:wp14="http://schemas.microsoft.com/office/word/2010/wordprocessingDrawing" xmlns:mc="http://schemas.openxmlformats.org/markup-compatibility/2006" xmlns:sl="http://schemas.openxmlformats.org/schemaLibrary/2006/main" xmlns:wne="http://schemas.microsoft.com/office/word/2006/wordml" xmlns:cdr="http://schemas.openxmlformats.org/drawingml/2006/chartDrawing" xmlns:c14="http://schemas.microsoft.com/office/drawing/2007/8/2/chart" xmlns:dgm="http://schemas.openxmlformats.org/drawingml/2006/diagram" xmlns:pic="http://schemas.openxmlformats.org/drawingml/2006/picture" xmlns:xdr="http://schemas.openxmlformats.org/drawingml/2006/spreadsheetDrawing" xmlns:dsp="http://schemas.microsoft.com/office/drawing/2008/diagram" xmlns:xvml="urn:schemas-microsoft-com:office:excel" xmlns:o="urn:schemas-microsoft-com:office:office" xmlns:v="urn:schemas-microsoft-com:vml" xmlns:w10="urn:schemas-microsoft-com:office:word" xmlns:pvml="urn:schemas-microsoft-com:office:powerpoint" xmlns:cppr="http://schemas.microsoft.com/office/2006/coverPageProps" xmlns:odx="http://opendope.org/xpaths" xmlns:odc="http://opendope.org/conditions" xmlns:odq="http://opendope.org/questions" xmlns:oda="http://opendope.org/answers" xmlns:odi="http://opendope.org/components" xmlns:odgm="http://opendope.org/SmartArt/DataHierarchy" xmlns:b="http://schemas.openxmlformats.org/officeDocument/2006/bibliography" xmlns:wps="http://schemas.microsoft.com/office/word/2010/wordprocessingShape" xmlns:w16se="http://schemas.microsoft.com/office/word/2015/wordml/symex" xmlns:w16cid="http://schemas.microsoft.com/office/word/2016/wordml/cid" xmlns:wetp="http://schemas.microsoft.com/office/webextensions/taskpanes/2010/11" xmlns:we="http://schemas.microsoft.com/office/webextensions/webextension/2010/11" xmlns:comp="http://schemas.openxmlformats.org/drawingml/2006/compatibility" xmlns:lc="http://schemas.openxmlformats.org/drawingml/2006/lockedCanvas">
+          <c:extLst xmlns:lc="http://schemas.openxmlformats.org/drawingml/2006/lockedCanvas" xmlns:comp="http://schemas.openxmlformats.org/drawingml/2006/compatibility" xmlns:we="http://schemas.microsoft.com/office/webextensions/webextension/2010/11" xmlns:wetp="http://schemas.microsoft.com/office/webextensions/taskpanes/2010/11" xmlns:w16cid="http://schemas.microsoft.com/office/word/2016/wordml/cid" xmlns:w16se="http://schemas.microsoft.com/office/word/2015/wordml/symex" xmlns:wps="http://schemas.microsoft.com/office/word/2010/wordprocessingShape" xmlns:b="http://schemas.openxmlformats.org/officeDocument/2006/bibliography" xmlns:odgm="http://opendope.org/SmartArt/DataHierarchy" xmlns:odi="http://opendope.org/components" xmlns:oda="http://opendope.org/answers" xmlns:odq="http://opendope.org/questions" xmlns:odc="http://opendope.org/conditions" xmlns:odx="http://opendope.org/xpaths" xmlns:cppr="http://schemas.microsoft.com/office/2006/coverPageProps" xmlns:pvml="urn:schemas-microsoft-com:office:powerpoint" xmlns:w10="urn:schemas-microsoft-com:office:word" xmlns:v="urn:schemas-microsoft-com:vml" xmlns:o="urn:schemas-microsoft-com:office:office" xmlns:xvml="urn:schemas-microsoft-com:office:excel" xmlns:dsp="http://schemas.microsoft.com/office/drawing/2008/diagram" xmlns:xdr="http://schemas.openxmlformats.org/drawingml/2006/spreadsheetDrawing" xmlns:pic="http://schemas.openxmlformats.org/drawingml/2006/picture" xmlns:dgm="http://schemas.openxmlformats.org/drawingml/2006/diagram" xmlns:c14="http://schemas.microsoft.com/office/drawing/2007/8/2/chart" xmlns:cdr="http://schemas.openxmlformats.org/drawingml/2006/chartDrawing" xmlns:wne="http://schemas.microsoft.com/office/word/2006/wordml" xmlns:sl="http://schemas.openxmlformats.org/schemaLibrary/2006/main" xmlns:mc="http://schemas.openxmlformats.org/markup-compatibility/2006" xmlns:wp14="http://schemas.microsoft.com/office/word/2010/wordprocessingDrawing" xmlns:wp="http://schemas.openxmlformats.org/drawingml/2006/wordprocessingDrawing" xmlns:m="http://schemas.openxmlformats.org/officeDocument/2006/math" xmlns:w14="http://schemas.microsoft.com/office/word/2010/wordml" xmlns:w15="http://schemas.microsoft.com/office/word/2012/wordml" xmlns:w="http://schemas.openxmlformats.org/wordprocessingml/2006/main">
             <c:ext xmlns:c16="http://schemas.microsoft.com/office/drawing/2014/chart" uri="{C3380CC4-5D6E-409C-BE32-E72D297353CC}">
               <c16:uniqueId val="{00000001-7C96-CF4F-94AD-E08A5CD6D25E}"/>
             </c:ext>
@@ -589,7 +589,7 @@
     <c:plotVisOnly val="1"/>
     <c:dispBlanksAs val="gap"/>
     <c:showDLblsOverMax val="0"/>
-    <c:extLst xmlns:w="http://schemas.openxmlformats.org/wordprocessingml/2006/main" xmlns:w15="http://schemas.microsoft.com/office/word/2012/wordml" xmlns:w14="http://schemas.microsoft.com/office/word/2010/wordml" xmlns:m="http://schemas.openxmlformats.org/officeDocument/2006/math" xmlns:wp="http://schemas.openxmlformats.org/drawingml/2006/wordprocessingDrawing" xmlns:wp14="http://schemas.microsoft.com/office/word/2010/wordprocessingDrawing" xmlns:mc="http://schemas.openxmlformats.org/markup-compatibility/2006" xmlns:sl="http://schemas.openxmlformats.org/schemaLibrary/2006/main" xmlns:wne="http://schemas.microsoft.com/office/word/2006/wordml" xmlns:cdr="http://schemas.openxmlformats.org/drawingml/2006/chartDrawing" xmlns:c14="http://schemas.microsoft.com/office/drawing/2007/8/2/chart" xmlns:dgm="http://schemas.openxmlformats.org/drawingml/2006/diagram" xmlns:pic="http://schemas.openxmlformats.org/drawingml/2006/picture" xmlns:xdr="http://schemas.openxmlformats.org/drawingml/2006/spreadsheetDrawing" xmlns:dsp="http://schemas.microsoft.com/office/drawing/2008/diagram" xmlns:xvml="urn:schemas-microsoft-com:office:excel" xmlns:o="urn:schemas-microsoft-com:office:office" xmlns:v="urn:schemas-microsoft-com:vml" xmlns:w10="urn:schemas-microsoft-com:office:word" xmlns:pvml="urn:schemas-microsoft-com:office:powerpoint" xmlns:cppr="http://schemas.microsoft.com/office/2006/coverPageProps" xmlns:odx="http://opendope.org/xpaths" xmlns:odc="http://opendope.org/conditions" xmlns:odq="http://opendope.org/questions" xmlns:oda="http://opendope.org/answers" xmlns:odi="http://opendope.org/components" xmlns:odgm="http://opendope.org/SmartArt/DataHierarchy" xmlns:b="http://schemas.openxmlformats.org/officeDocument/2006/bibliography" xmlns:wps="http://schemas.microsoft.com/office/word/2010/wordprocessingShape" xmlns:w16se="http://schemas.microsoft.com/office/word/2015/wordml/symex" xmlns:w16cid="http://schemas.microsoft.com/office/word/2016/wordml/cid" xmlns:wetp="http://schemas.microsoft.com/office/webextensions/taskpanes/2010/11" xmlns:we="http://schemas.microsoft.com/office/webextensions/webextension/2010/11" xmlns:comp="http://schemas.openxmlformats.org/drawingml/2006/compatibility" xmlns:lc="http://schemas.openxmlformats.org/drawingml/2006/lockedCanvas">
+    <c:extLst xmlns:lc="http://schemas.openxmlformats.org/drawingml/2006/lockedCanvas" xmlns:comp="http://schemas.openxmlformats.org/drawingml/2006/compatibility" xmlns:we="http://schemas.microsoft.com/office/webextensions/webextension/2010/11" xmlns:wetp="http://schemas.microsoft.com/office/webextensions/taskpanes/2010/11" xmlns:w16cid="http://schemas.microsoft.com/office/word/2016/wordml/cid" xmlns:w16se="http://schemas.microsoft.com/office/word/2015/wordml/symex" xmlns:wps="http://schemas.microsoft.com/office/word/2010/wordprocessingShape" xmlns:b="http://schemas.openxmlformats.org/officeDocument/2006/bibliography" xmlns:odgm="http://opendope.org/SmartArt/DataHierarchy" xmlns:odi="http://opendope.org/components" xmlns:oda="http://opendope.org/answers" xmlns:odq="http://opendope.org/questions" xmlns:odc="http://opendope.org/conditions" xmlns:odx="http://opendope.org/xpaths" xmlns:cppr="http://schemas.microsoft.com/office/2006/coverPageProps" xmlns:pvml="urn:schemas-microsoft-com:office:powerpoint" xmlns:w10="urn:schemas-microsoft-com:office:word" xmlns:v="urn:schemas-microsoft-com:vml" xmlns:o="urn:schemas-microsoft-com:office:office" xmlns:xvml="urn:schemas-microsoft-com:office:excel" xmlns:dsp="http://schemas.microsoft.com/office/drawing/2008/diagram" xmlns:xdr="http://schemas.openxmlformats.org/drawingml/2006/spreadsheetDrawing" xmlns:pic="http://schemas.openxmlformats.org/drawingml/2006/picture" xmlns:dgm="http://schemas.openxmlformats.org/drawingml/2006/diagram" xmlns:c14="http://schemas.microsoft.com/office/drawing/2007/8/2/chart" xmlns:cdr="http://schemas.openxmlformats.org/drawingml/2006/chartDrawing" xmlns:wne="http://schemas.microsoft.com/office/word/2006/wordml" xmlns:sl="http://schemas.openxmlformats.org/schemaLibrary/2006/main" xmlns:mc="http://schemas.openxmlformats.org/markup-compatibility/2006" xmlns:wp14="http://schemas.microsoft.com/office/word/2010/wordprocessingDrawing" xmlns:wp="http://schemas.openxmlformats.org/drawingml/2006/wordprocessingDrawing" xmlns:m="http://schemas.openxmlformats.org/officeDocument/2006/math" xmlns:w14="http://schemas.microsoft.com/office/word/2010/wordml" xmlns:w15="http://schemas.microsoft.com/office/word/2012/wordml" xmlns:w="http://schemas.openxmlformats.org/wordprocessingml/2006/main">
       <c:ext xmlns:c16r3="http://schemas.microsoft.com/office/drawing/2017/03/chart" uri="{56B9EC1D-385E-4148-901F-78D8002777C0}">
         <c16r3:dataDisplayOptions16>
           <c16r3:dispNaAsBlank val="1"/>
@@ -5068,7 +5068,7 @@
           <a:p>
             <a:fld id="{C1255C68-584F-174D-BB81-51BF91708794}" type="datetimeFigureOut">
               <a:rPr lang="en-US" smtClean="0"/>
-              <a:t>4/14/26</a:t>
+              <a:t>5/19/26</a:t>
             </a:fld>
             <a:endParaRPr lang="en-US"/>
           </a:p>
@@ -5261,7 +5261,7 @@
           <a:p>
             <a:fld id="{A1EDAAC4-819D-C544-9EA1-C73624CFD70B}" type="datetimeFigureOut">
               <a:rPr lang="en-US" smtClean="0"/>
-              <a:t>4/14/26</a:t>
+              <a:t>5/19/26</a:t>
             </a:fld>
             <a:endParaRPr lang="en-US"/>
           </a:p>
@@ -6455,10 +6455,31 @@
           </a:lstStyle>
           <a:p>
             <a:r>
-              <a:rPr lang="nl-NL"/>
-              <a:t>Confidential</a:t>
-            </a:r>
-            <a:endParaRPr lang="nl-NL" dirty="0"/>
+              <a:rPr lang="nl-NL" dirty="0" err="1"/>
+              <a:t>Generated</a:t>
+            </a:r>
+            <a:r>
+              <a:rPr lang="nl-NL" dirty="0"/>
+              <a:t> </a:t>
+            </a:r>
+            <a:r>
+              <a:rPr lang="nl-NL" dirty="0" err="1"/>
+              <a:t>with</a:t>
+            </a:r>
+            <a:r>
+              <a:rPr lang="nl-NL" dirty="0"/>
+              <a:t> Sigrid</a:t>
+            </a:r>
+          </a:p>
+          <a:p>
+            <a:r>
+              <a:rPr lang="nl-NL" dirty="0" err="1"/>
+              <a:t>for</a:t>
+            </a:r>
+            <a:r>
+              <a:rPr lang="nl-NL" dirty="0"/>
+              <a:t> CUSTOMER_NAME</a:t>
+            </a:r>
           </a:p>
         </p:txBody>
       </p:sp>
@@ -6674,51 +6695,6 @@
       </p:sp>
       <p:sp>
         <p:nvSpPr>
-          <p:cNvPr id="2" name="Tijdelijke aanduiding voor voettekst 1">
-            <a:extLst>
-              <a:ext uri="{FF2B5EF4-FFF2-40B4-BE49-F238E27FC236}">
-                <a16:creationId xmlns:a16="http://schemas.microsoft.com/office/drawing/2014/main" id="{D962B193-53CA-0D19-0118-C61D7DEBCFE8}"/>
-              </a:ext>
-            </a:extLst>
-          </p:cNvPr>
-          <p:cNvSpPr>
-            <a:spLocks noGrp="1"/>
-          </p:cNvSpPr>
-          <p:nvPr>
-            <p:ph type="ftr" sz="quarter" idx="14"/>
-          </p:nvPr>
-        </p:nvSpPr>
-        <p:spPr>
-          <a:xfrm>
-            <a:off x="849600" y="6462000"/>
-            <a:ext cx="1085851" cy="231923"/>
-          </a:xfrm>
-          <a:prstGeom prst="rect">
-            <a:avLst/>
-          </a:prstGeom>
-        </p:spPr>
-        <p:txBody>
-          <a:bodyPr/>
-          <a:lstStyle>
-            <a:lvl1pPr>
-              <a:defRPr>
-                <a:solidFill>
-                  <a:srgbClr val="FFFFFF"/>
-                </a:solidFill>
-              </a:defRPr>
-            </a:lvl1pPr>
-          </a:lstStyle>
-          <a:p>
-            <a:r>
-              <a:rPr lang="nl-NL"/>
-              <a:t>Confidential</a:t>
-            </a:r>
-            <a:endParaRPr lang="nl-NL" dirty="0"/>
-          </a:p>
-        </p:txBody>
-      </p:sp>
-      <p:sp>
-        <p:nvSpPr>
           <p:cNvPr id="3" name="Tijdelijke aanduiding voor dianummer 2">
             <a:extLst>
               <a:ext uri="{FF2B5EF4-FFF2-40B4-BE49-F238E27FC236}">
@@ -6995,6 +6971,72 @@
           </a:p>
         </p:txBody>
       </p:sp>
+      <p:sp>
+        <p:nvSpPr>
+          <p:cNvPr id="5" name="Tijdelijke aanduiding voor voettekst 1">
+            <a:extLst>
+              <a:ext uri="{FF2B5EF4-FFF2-40B4-BE49-F238E27FC236}">
+                <a16:creationId xmlns:a16="http://schemas.microsoft.com/office/drawing/2014/main" id="{8556F523-A34B-5585-A9B1-130109078882}"/>
+              </a:ext>
+            </a:extLst>
+          </p:cNvPr>
+          <p:cNvSpPr>
+            <a:spLocks noGrp="1"/>
+          </p:cNvSpPr>
+          <p:nvPr>
+            <p:ph type="ftr" sz="quarter" idx="14"/>
+          </p:nvPr>
+        </p:nvSpPr>
+        <p:spPr>
+          <a:xfrm>
+            <a:off x="192158" y="6392274"/>
+            <a:ext cx="1763922" cy="370422"/>
+          </a:xfrm>
+          <a:prstGeom prst="rect">
+            <a:avLst/>
+          </a:prstGeom>
+        </p:spPr>
+        <p:txBody>
+          <a:bodyPr/>
+          <a:lstStyle>
+            <a:lvl1pPr>
+              <a:defRPr>
+                <a:solidFill>
+                  <a:schemeClr val="bg1"/>
+                </a:solidFill>
+              </a:defRPr>
+            </a:lvl1pPr>
+          </a:lstStyle>
+          <a:p>
+            <a:r>
+              <a:rPr lang="nl-NL" dirty="0" err="1"/>
+              <a:t>Generated</a:t>
+            </a:r>
+            <a:r>
+              <a:rPr lang="nl-NL" dirty="0"/>
+              <a:t> </a:t>
+            </a:r>
+            <a:r>
+              <a:rPr lang="nl-NL" dirty="0" err="1"/>
+              <a:t>with</a:t>
+            </a:r>
+            <a:r>
+              <a:rPr lang="nl-NL" dirty="0"/>
+              <a:t> Sigrid</a:t>
+            </a:r>
+          </a:p>
+          <a:p>
+            <a:r>
+              <a:rPr lang="nl-NL" dirty="0" err="1"/>
+              <a:t>for</a:t>
+            </a:r>
+            <a:r>
+              <a:rPr lang="nl-NL" dirty="0"/>
+              <a:t> CUSTOMER_NAME</a:t>
+            </a:r>
+          </a:p>
+        </p:txBody>
+      </p:sp>
     </p:spTree>
     <p:extLst>
       <p:ext uri="{BB962C8B-B14F-4D97-AF65-F5344CB8AC3E}">
@@ -7151,8 +7193,8 @@
         </p:nvSpPr>
         <p:spPr>
           <a:xfrm>
-            <a:off x="849600" y="6462000"/>
-            <a:ext cx="1085851" cy="231923"/>
+            <a:off x="192158" y="6392274"/>
+            <a:ext cx="1763922" cy="370422"/>
           </a:xfrm>
           <a:prstGeom prst="rect">
             <a:avLst/>
@@ -7164,9 +7206,30 @@
           <a:p>
             <a:r>
               <a:rPr lang="nl-NL" dirty="0" err="1"/>
-              <a:t>Confidential</a:t>
-            </a:r>
-            <a:endParaRPr lang="nl-NL" dirty="0"/>
+              <a:t>Generated</a:t>
+            </a:r>
+            <a:r>
+              <a:rPr lang="nl-NL" dirty="0"/>
+              <a:t> </a:t>
+            </a:r>
+            <a:r>
+              <a:rPr lang="nl-NL" dirty="0" err="1"/>
+              <a:t>with</a:t>
+            </a:r>
+            <a:r>
+              <a:rPr lang="nl-NL" dirty="0"/>
+              <a:t> Sigrid</a:t>
+            </a:r>
+          </a:p>
+          <a:p>
+            <a:r>
+              <a:rPr lang="nl-NL" dirty="0" err="1"/>
+              <a:t>for</a:t>
+            </a:r>
+            <a:r>
+              <a:rPr lang="nl-NL" dirty="0"/>
+              <a:t> CUSTOMER_NAME</a:t>
+            </a:r>
           </a:p>
         </p:txBody>
       </p:sp>
@@ -7397,43 +7460,6 @@
       </p:sp>
       <p:sp>
         <p:nvSpPr>
-          <p:cNvPr id="2" name="Tijdelijke aanduiding voor voettekst 1">
-            <a:extLst>
-              <a:ext uri="{FF2B5EF4-FFF2-40B4-BE49-F238E27FC236}">
-                <a16:creationId xmlns:a16="http://schemas.microsoft.com/office/drawing/2014/main" id="{E3DFEFF2-832D-3790-5F9D-5A5E200E718B}"/>
-              </a:ext>
-            </a:extLst>
-          </p:cNvPr>
-          <p:cNvSpPr>
-            <a:spLocks noGrp="1"/>
-          </p:cNvSpPr>
-          <p:nvPr>
-            <p:ph type="ftr" sz="quarter" idx="14"/>
-          </p:nvPr>
-        </p:nvSpPr>
-        <p:spPr>
-          <a:xfrm>
-            <a:off x="849600" y="6462000"/>
-            <a:ext cx="1085851" cy="231923"/>
-          </a:xfrm>
-          <a:prstGeom prst="rect">
-            <a:avLst/>
-          </a:prstGeom>
-        </p:spPr>
-        <p:txBody>
-          <a:bodyPr/>
-          <a:lstStyle/>
-          <a:p>
-            <a:r>
-              <a:rPr lang="nl-NL" dirty="0" err="1"/>
-              <a:t>Confidential</a:t>
-            </a:r>
-            <a:endParaRPr lang="nl-NL" dirty="0"/>
-          </a:p>
-        </p:txBody>
-      </p:sp>
-      <p:sp>
-        <p:nvSpPr>
           <p:cNvPr id="3" name="Tijdelijke aanduiding voor dianummer 2">
             <a:extLst>
               <a:ext uri="{FF2B5EF4-FFF2-40B4-BE49-F238E27FC236}">
@@ -7578,6 +7604,64 @@
                 <a:schemeClr val="accent1"/>
               </a:solidFill>
             </a:endParaRPr>
+          </a:p>
+        </p:txBody>
+      </p:sp>
+      <p:sp>
+        <p:nvSpPr>
+          <p:cNvPr id="7" name="Tijdelijke aanduiding voor voettekst 1">
+            <a:extLst>
+              <a:ext uri="{FF2B5EF4-FFF2-40B4-BE49-F238E27FC236}">
+                <a16:creationId xmlns:a16="http://schemas.microsoft.com/office/drawing/2014/main" id="{A037B3EB-E786-732F-38F1-CF6E5940C1B9}"/>
+              </a:ext>
+            </a:extLst>
+          </p:cNvPr>
+          <p:cNvSpPr>
+            <a:spLocks noGrp="1"/>
+          </p:cNvSpPr>
+          <p:nvPr>
+            <p:ph type="ftr" sz="quarter" idx="14"/>
+          </p:nvPr>
+        </p:nvSpPr>
+        <p:spPr>
+          <a:xfrm>
+            <a:off x="192158" y="6392274"/>
+            <a:ext cx="1763922" cy="370422"/>
+          </a:xfrm>
+          <a:prstGeom prst="rect">
+            <a:avLst/>
+          </a:prstGeom>
+        </p:spPr>
+        <p:txBody>
+          <a:bodyPr/>
+          <a:lstStyle/>
+          <a:p>
+            <a:r>
+              <a:rPr lang="nl-NL" dirty="0" err="1"/>
+              <a:t>Generated</a:t>
+            </a:r>
+            <a:r>
+              <a:rPr lang="nl-NL" dirty="0"/>
+              <a:t> </a:t>
+            </a:r>
+            <a:r>
+              <a:rPr lang="nl-NL" dirty="0" err="1"/>
+              <a:t>with</a:t>
+            </a:r>
+            <a:r>
+              <a:rPr lang="nl-NL" dirty="0"/>
+              <a:t> Sigrid</a:t>
+            </a:r>
+          </a:p>
+          <a:p>
+            <a:r>
+              <a:rPr lang="nl-NL" dirty="0" err="1"/>
+              <a:t>for</a:t>
+            </a:r>
+            <a:r>
+              <a:rPr lang="nl-NL" dirty="0"/>
+              <a:t> CUSTOMER_NAME</a:t>
+            </a:r>
           </a:p>
         </p:txBody>
       </p:sp>
@@ -8419,8 +8503,8 @@
         </p:nvSpPr>
         <p:spPr>
           <a:xfrm>
-            <a:off x="849600" y="6462000"/>
-            <a:ext cx="1085851" cy="231923"/>
+            <a:off x="191689" y="6391201"/>
+            <a:ext cx="1763922" cy="370422"/>
           </a:xfrm>
           <a:prstGeom prst="rect">
             <a:avLst/>
@@ -8463,8 +8547,30 @@
           </a:lstStyle>
           <a:p>
             <a:r>
-              <a:rPr lang="nl-NL"/>
-              <a:t>Confidential</a:t>
+              <a:rPr lang="nl-NL" dirty="0" err="1"/>
+              <a:t>Generated</a:t>
+            </a:r>
+            <a:r>
+              <a:rPr lang="nl-NL" dirty="0"/>
+              <a:t> </a:t>
+            </a:r>
+            <a:r>
+              <a:rPr lang="nl-NL" dirty="0" err="1"/>
+              <a:t>with</a:t>
+            </a:r>
+            <a:r>
+              <a:rPr lang="nl-NL" dirty="0"/>
+              <a:t> Sigrid</a:t>
+            </a:r>
+          </a:p>
+          <a:p>
+            <a:r>
+              <a:rPr lang="nl-NL" dirty="0" err="1"/>
+              <a:t>for</a:t>
+            </a:r>
+            <a:r>
+              <a:rPr lang="nl-NL" dirty="0"/>
+              <a:t> CUSTOMER_NAME</a:t>
             </a:r>
           </a:p>
         </p:txBody>
@@ -9089,8 +9195,30 @@
           <a:lstStyle/>
           <a:p>
             <a:r>
-              <a:rPr lang="en-GB" dirty="0"/>
-              <a:t>Confidential</a:t>
+              <a:rPr lang="nl-NL" dirty="0" err="1"/>
+              <a:t>Generated</a:t>
+            </a:r>
+            <a:r>
+              <a:rPr lang="nl-NL" dirty="0"/>
+              <a:t> </a:t>
+            </a:r>
+            <a:r>
+              <a:rPr lang="nl-NL" dirty="0" err="1"/>
+              <a:t>with</a:t>
+            </a:r>
+            <a:r>
+              <a:rPr lang="nl-NL" dirty="0"/>
+              <a:t> Sigrid</a:t>
+            </a:r>
+          </a:p>
+          <a:p>
+            <a:r>
+              <a:rPr lang="nl-NL" dirty="0" err="1"/>
+              <a:t>for</a:t>
+            </a:r>
+            <a:r>
+              <a:rPr lang="nl-NL" dirty="0"/>
+              <a:t> CUSTOMER_NAME</a:t>
             </a:r>
           </a:p>
         </p:txBody>
@@ -9279,6 +9407,64 @@
             <a:r>
               <a:rPr lang="en-US" dirty="0"/>
               <a:t>Results in Sigrid become more accurate and useful the more systems have the metadata filled in.</a:t>
+            </a:r>
+          </a:p>
+        </p:txBody>
+      </p:sp>
+      <p:sp>
+        <p:nvSpPr>
+          <p:cNvPr id="5" name="Tijdelijke aanduiding voor voettekst 1">
+            <a:extLst>
+              <a:ext uri="{FF2B5EF4-FFF2-40B4-BE49-F238E27FC236}">
+                <a16:creationId xmlns:a16="http://schemas.microsoft.com/office/drawing/2014/main" id="{ED329E08-158C-2F45-4B52-8064310DBF2D}"/>
+              </a:ext>
+            </a:extLst>
+          </p:cNvPr>
+          <p:cNvSpPr>
+            <a:spLocks noGrp="1"/>
+          </p:cNvSpPr>
+          <p:nvPr>
+            <p:ph type="ftr" sz="quarter" idx="14"/>
+          </p:nvPr>
+        </p:nvSpPr>
+        <p:spPr>
+          <a:xfrm>
+            <a:off x="192158" y="6392274"/>
+            <a:ext cx="1763922" cy="370422"/>
+          </a:xfrm>
+          <a:prstGeom prst="rect">
+            <a:avLst/>
+          </a:prstGeom>
+        </p:spPr>
+        <p:txBody>
+          <a:bodyPr/>
+          <a:lstStyle/>
+          <a:p>
+            <a:r>
+              <a:rPr lang="nl-NL" dirty="0" err="1"/>
+              <a:t>Generated</a:t>
+            </a:r>
+            <a:r>
+              <a:rPr lang="nl-NL" dirty="0"/>
+              <a:t> </a:t>
+            </a:r>
+            <a:r>
+              <a:rPr lang="nl-NL" dirty="0" err="1"/>
+              <a:t>with</a:t>
+            </a:r>
+            <a:r>
+              <a:rPr lang="nl-NL" dirty="0"/>
+              <a:t> Sigrid</a:t>
+            </a:r>
+          </a:p>
+          <a:p>
+            <a:r>
+              <a:rPr lang="nl-NL" dirty="0" err="1"/>
+              <a:t>for</a:t>
+            </a:r>
+            <a:r>
+              <a:rPr lang="nl-NL" dirty="0"/>
+              <a:t> CUSTOMER_NAME</a:t>
             </a:r>
           </a:p>
         </p:txBody>
@@ -9477,6 +9663,64 @@
           </a:p>
         </p:txBody>
       </p:sp>
+      <p:sp>
+        <p:nvSpPr>
+          <p:cNvPr id="6" name="Tijdelijke aanduiding voor voettekst 1">
+            <a:extLst>
+              <a:ext uri="{FF2B5EF4-FFF2-40B4-BE49-F238E27FC236}">
+                <a16:creationId xmlns:a16="http://schemas.microsoft.com/office/drawing/2014/main" id="{88F4BDDD-26CC-6BC7-8090-B7DB45E20E4B}"/>
+              </a:ext>
+            </a:extLst>
+          </p:cNvPr>
+          <p:cNvSpPr>
+            <a:spLocks noGrp="1"/>
+          </p:cNvSpPr>
+          <p:nvPr>
+            <p:ph type="ftr" sz="quarter" idx="14"/>
+          </p:nvPr>
+        </p:nvSpPr>
+        <p:spPr>
+          <a:xfrm>
+            <a:off x="192158" y="6392274"/>
+            <a:ext cx="1763922" cy="370422"/>
+          </a:xfrm>
+          <a:prstGeom prst="rect">
+            <a:avLst/>
+          </a:prstGeom>
+        </p:spPr>
+        <p:txBody>
+          <a:bodyPr/>
+          <a:lstStyle/>
+          <a:p>
+            <a:r>
+              <a:rPr lang="nl-NL" dirty="0" err="1"/>
+              <a:t>Generated</a:t>
+            </a:r>
+            <a:r>
+              <a:rPr lang="nl-NL" dirty="0"/>
+              <a:t> </a:t>
+            </a:r>
+            <a:r>
+              <a:rPr lang="nl-NL" dirty="0" err="1"/>
+              <a:t>with</a:t>
+            </a:r>
+            <a:r>
+              <a:rPr lang="nl-NL" dirty="0"/>
+              <a:t> Sigrid</a:t>
+            </a:r>
+          </a:p>
+          <a:p>
+            <a:r>
+              <a:rPr lang="nl-NL" dirty="0" err="1"/>
+              <a:t>for</a:t>
+            </a:r>
+            <a:r>
+              <a:rPr lang="nl-NL" dirty="0"/>
+              <a:t> CUSTOMER_NAME</a:t>
+            </a:r>
+          </a:p>
+        </p:txBody>
+      </p:sp>
     </p:spTree>
     <p:extLst>
       <p:ext uri="{BB962C8B-B14F-4D97-AF65-F5344CB8AC3E}">
@@ -9672,6 +9916,64 @@
           </a:graphicData>
         </a:graphic>
       </p:graphicFrame>
+      <p:sp>
+        <p:nvSpPr>
+          <p:cNvPr id="6" name="Tijdelijke aanduiding voor voettekst 1">
+            <a:extLst>
+              <a:ext uri="{FF2B5EF4-FFF2-40B4-BE49-F238E27FC236}">
+                <a16:creationId xmlns:a16="http://schemas.microsoft.com/office/drawing/2014/main" id="{4885D28E-1809-E8B3-2ECF-6BAA9B43790B}"/>
+              </a:ext>
+            </a:extLst>
+          </p:cNvPr>
+          <p:cNvSpPr>
+            <a:spLocks noGrp="1"/>
+          </p:cNvSpPr>
+          <p:nvPr>
+            <p:ph type="ftr" sz="quarter" idx="14"/>
+          </p:nvPr>
+        </p:nvSpPr>
+        <p:spPr>
+          <a:xfrm>
+            <a:off x="192158" y="6392274"/>
+            <a:ext cx="1763922" cy="370422"/>
+          </a:xfrm>
+          <a:prstGeom prst="rect">
+            <a:avLst/>
+          </a:prstGeom>
+        </p:spPr>
+        <p:txBody>
+          <a:bodyPr/>
+          <a:lstStyle/>
+          <a:p>
+            <a:r>
+              <a:rPr lang="nl-NL" dirty="0" err="1"/>
+              <a:t>Generated</a:t>
+            </a:r>
+            <a:r>
+              <a:rPr lang="nl-NL" dirty="0"/>
+              <a:t> </a:t>
+            </a:r>
+            <a:r>
+              <a:rPr lang="nl-NL" dirty="0" err="1"/>
+              <a:t>with</a:t>
+            </a:r>
+            <a:r>
+              <a:rPr lang="nl-NL" dirty="0"/>
+              <a:t> Sigrid</a:t>
+            </a:r>
+          </a:p>
+          <a:p>
+            <a:r>
+              <a:rPr lang="nl-NL" dirty="0" err="1"/>
+              <a:t>for</a:t>
+            </a:r>
+            <a:r>
+              <a:rPr lang="nl-NL" dirty="0"/>
+              <a:t> CUSTOMER_NAME</a:t>
+            </a:r>
+          </a:p>
+        </p:txBody>
+      </p:sp>
     </p:spTree>
     <p:extLst>
       <p:ext uri="{BB962C8B-B14F-4D97-AF65-F5344CB8AC3E}">
@@ -9867,6 +10169,64 @@
           </a:p>
         </p:txBody>
       </p:sp>
+      <p:sp>
+        <p:nvSpPr>
+          <p:cNvPr id="6" name="Tijdelijke aanduiding voor voettekst 1">
+            <a:extLst>
+              <a:ext uri="{FF2B5EF4-FFF2-40B4-BE49-F238E27FC236}">
+                <a16:creationId xmlns:a16="http://schemas.microsoft.com/office/drawing/2014/main" id="{DAB79EF4-00FB-BE40-5AFD-EEFC4BB0F282}"/>
+              </a:ext>
+            </a:extLst>
+          </p:cNvPr>
+          <p:cNvSpPr>
+            <a:spLocks noGrp="1"/>
+          </p:cNvSpPr>
+          <p:nvPr>
+            <p:ph type="ftr" sz="quarter" idx="14"/>
+          </p:nvPr>
+        </p:nvSpPr>
+        <p:spPr>
+          <a:xfrm>
+            <a:off x="192158" y="6392274"/>
+            <a:ext cx="1763922" cy="370422"/>
+          </a:xfrm>
+          <a:prstGeom prst="rect">
+            <a:avLst/>
+          </a:prstGeom>
+        </p:spPr>
+        <p:txBody>
+          <a:bodyPr/>
+          <a:lstStyle/>
+          <a:p>
+            <a:r>
+              <a:rPr lang="nl-NL" dirty="0" err="1"/>
+              <a:t>Generated</a:t>
+            </a:r>
+            <a:r>
+              <a:rPr lang="nl-NL" dirty="0"/>
+              <a:t> </a:t>
+            </a:r>
+            <a:r>
+              <a:rPr lang="nl-NL" dirty="0" err="1"/>
+              <a:t>with</a:t>
+            </a:r>
+            <a:r>
+              <a:rPr lang="nl-NL" dirty="0"/>
+              <a:t> Sigrid</a:t>
+            </a:r>
+          </a:p>
+          <a:p>
+            <a:r>
+              <a:rPr lang="nl-NL" dirty="0" err="1"/>
+              <a:t>for</a:t>
+            </a:r>
+            <a:r>
+              <a:rPr lang="nl-NL" dirty="0"/>
+              <a:t> CUSTOMER_NAME</a:t>
+            </a:r>
+          </a:p>
+        </p:txBody>
+      </p:sp>
     </p:spTree>
     <p:extLst>
       <p:ext uri="{BB962C8B-B14F-4D97-AF65-F5344CB8AC3E}">
@@ -10049,6 +10409,64 @@
             <a:r>
               <a:rPr lang="en-US" dirty="0"/>
               <a:t>Having objectives set in Sigrid helps your teams to track the quality of the portfolio and gradually improve it over time.</a:t>
+            </a:r>
+          </a:p>
+        </p:txBody>
+      </p:sp>
+      <p:sp>
+        <p:nvSpPr>
+          <p:cNvPr id="7" name="Tijdelijke aanduiding voor voettekst 1">
+            <a:extLst>
+              <a:ext uri="{FF2B5EF4-FFF2-40B4-BE49-F238E27FC236}">
+                <a16:creationId xmlns:a16="http://schemas.microsoft.com/office/drawing/2014/main" id="{7A66FFB7-3982-7256-9FEA-8AC335FFAF52}"/>
+              </a:ext>
+            </a:extLst>
+          </p:cNvPr>
+          <p:cNvSpPr>
+            <a:spLocks noGrp="1"/>
+          </p:cNvSpPr>
+          <p:nvPr>
+            <p:ph type="ftr" sz="quarter" idx="14"/>
+          </p:nvPr>
+        </p:nvSpPr>
+        <p:spPr>
+          <a:xfrm>
+            <a:off x="192158" y="6392274"/>
+            <a:ext cx="1763922" cy="370422"/>
+          </a:xfrm>
+          <a:prstGeom prst="rect">
+            <a:avLst/>
+          </a:prstGeom>
+        </p:spPr>
+        <p:txBody>
+          <a:bodyPr/>
+          <a:lstStyle/>
+          <a:p>
+            <a:r>
+              <a:rPr lang="nl-NL" dirty="0" err="1"/>
+              <a:t>Generated</a:t>
+            </a:r>
+            <a:r>
+              <a:rPr lang="nl-NL" dirty="0"/>
+              <a:t> </a:t>
+            </a:r>
+            <a:r>
+              <a:rPr lang="nl-NL" dirty="0" err="1"/>
+              <a:t>with</a:t>
+            </a:r>
+            <a:r>
+              <a:rPr lang="nl-NL" dirty="0"/>
+              <a:t> Sigrid</a:t>
+            </a:r>
+          </a:p>
+          <a:p>
+            <a:r>
+              <a:rPr lang="nl-NL" dirty="0" err="1"/>
+              <a:t>for</a:t>
+            </a:r>
+            <a:r>
+              <a:rPr lang="nl-NL" dirty="0"/>
+              <a:t> CUSTOMER_NAME</a:t>
             </a:r>
           </a:p>
         </p:txBody>
@@ -10969,6 +11387,21 @@
 </file>
 
 <file path=customXml/item1.xml><?xml version="1.0" encoding="utf-8"?>
+<?mso-contentType ?>
+<FormTemplates xmlns="http://schemas.microsoft.com/sharepoint/v3/contenttype/forms">
+  <Display>DocumentLibraryForm</Display>
+  <Edit>DocumentLibraryForm</Edit>
+  <New>DocumentLibraryForm</New>
+</FormTemplates>
+</file>
+
+<file path=customXml/item2.xml><?xml version="1.0" encoding="utf-8"?>
+<p:properties xmlns:p="http://schemas.microsoft.com/office/2006/metadata/properties" xmlns:xsi="http://www.w3.org/2001/XMLSchema-instance" xmlns:pc="http://schemas.microsoft.com/office/infopath/2007/PartnerControls">
+  <documentManagement/>
+</p:properties>
+</file>
+
+<file path=customXml/item3.xml><?xml version="1.0" encoding="utf-8"?>
 <ct:contentTypeSchema xmlns:ct="http://schemas.microsoft.com/office/2006/metadata/contentType" xmlns:ma="http://schemas.microsoft.com/office/2006/metadata/properties/metaAttributes" ct:_="" ma:_="" ma:contentTypeName="Document" ma:contentTypeID="0x0101004DEF897B6A9E5243A3BAB7B7BDA55B95" ma:contentTypeVersion="3" ma:contentTypeDescription="Een nieuw document maken." ma:contentTypeScope="" ma:versionID="0a97628efbdf127f23042160181f1d9a">
   <xsd:schema xmlns:xsd="http://www.w3.org/2001/XMLSchema" xmlns:xs="http://www.w3.org/2001/XMLSchema" xmlns:p="http://schemas.microsoft.com/office/2006/metadata/properties" xmlns:ns2="444ebd02-7183-4d1c-abe9-f175efe83725" targetNamespace="http://schemas.microsoft.com/office/2006/metadata/properties" ma:root="true" ma:fieldsID="44a7a3b93c857102c842f6fb1da07824" ns2:_="">
     <xsd:import namespace="444ebd02-7183-4d1c-abe9-f175efe83725"/>
@@ -11106,35 +11539,10 @@
 </ct:contentTypeSchema>
 </file>
 
-<file path=customXml/item2.xml><?xml version="1.0" encoding="utf-8"?>
-<p:properties xmlns:p="http://schemas.microsoft.com/office/2006/metadata/properties" xmlns:xsi="http://www.w3.org/2001/XMLSchema-instance" xmlns:pc="http://schemas.microsoft.com/office/infopath/2007/PartnerControls">
-  <documentManagement/>
-</p:properties>
-</file>
-
-<file path=customXml/item3.xml><?xml version="1.0" encoding="utf-8"?>
-<?mso-contentType ?>
-<FormTemplates xmlns="http://schemas.microsoft.com/sharepoint/v3/contenttype/forms">
-  <Display>DocumentLibraryForm</Display>
-  <Edit>DocumentLibraryForm</Edit>
-  <New>DocumentLibraryForm</New>
-</FormTemplates>
-</file>
-
 <file path=customXml/itemProps1.xml><?xml version="1.0" encoding="utf-8"?>
-<ds:datastoreItem xmlns:ds="http://schemas.openxmlformats.org/officeDocument/2006/customXml" ds:itemID="{3AFAF3E6-8A11-4BDC-9823-6F0ACEBB33D3}">
+<ds:datastoreItem xmlns:ds="http://schemas.openxmlformats.org/officeDocument/2006/customXml" ds:itemID="{88AD9160-B56A-4FCD-857D-8AE63521E7FB}">
   <ds:schemaRefs>
-    <ds:schemaRef ds:uri="http://schemas.microsoft.com/office/2006/metadata/contentType"/>
-    <ds:schemaRef ds:uri="http://schemas.microsoft.com/office/2006/metadata/properties/metaAttributes"/>
-    <ds:schemaRef ds:uri="http://www.w3.org/2001/XMLSchema"/>
-    <ds:schemaRef ds:uri="http://schemas.microsoft.com/office/2006/metadata/properties"/>
-    <ds:schemaRef ds:uri="444ebd02-7183-4d1c-abe9-f175efe83725"/>
-    <ds:schemaRef ds:uri="http://schemas.microsoft.com/office/2006/documentManagement/types"/>
-    <ds:schemaRef ds:uri="http://schemas.microsoft.com/office/infopath/2007/PartnerControls"/>
-    <ds:schemaRef ds:uri="http://schemas.openxmlformats.org/package/2006/metadata/core-properties"/>
-    <ds:schemaRef ds:uri="http://purl.org/dc/elements/1.1/"/>
-    <ds:schemaRef ds:uri="http://purl.org/dc/terms/"/>
-    <ds:schemaRef ds:uri="http://schemas.microsoft.com/internal/obd"/>
+    <ds:schemaRef ds:uri="http://schemas.microsoft.com/sharepoint/v3/contenttype/forms"/>
   </ds:schemaRefs>
 </ds:datastoreItem>
 </file>
@@ -11156,9 +11564,19 @@
 </file>
 
 <file path=customXml/itemProps3.xml><?xml version="1.0" encoding="utf-8"?>
-<ds:datastoreItem xmlns:ds="http://schemas.openxmlformats.org/officeDocument/2006/customXml" ds:itemID="{88AD9160-B56A-4FCD-857D-8AE63521E7FB}">
+<ds:datastoreItem xmlns:ds="http://schemas.openxmlformats.org/officeDocument/2006/customXml" ds:itemID="{3AFAF3E6-8A11-4BDC-9823-6F0ACEBB33D3}">
   <ds:schemaRefs>
-    <ds:schemaRef ds:uri="http://schemas.microsoft.com/sharepoint/v3/contenttype/forms"/>
+    <ds:schemaRef ds:uri="http://schemas.microsoft.com/office/2006/metadata/contentType"/>
+    <ds:schemaRef ds:uri="http://schemas.microsoft.com/office/2006/metadata/properties/metaAttributes"/>
+    <ds:schemaRef ds:uri="http://www.w3.org/2001/XMLSchema"/>
+    <ds:schemaRef ds:uri="http://schemas.microsoft.com/office/2006/metadata/properties"/>
+    <ds:schemaRef ds:uri="444ebd02-7183-4d1c-abe9-f175efe83725"/>
+    <ds:schemaRef ds:uri="http://schemas.microsoft.com/office/2006/documentManagement/types"/>
+    <ds:schemaRef ds:uri="http://schemas.microsoft.com/office/infopath/2007/PartnerControls"/>
+    <ds:schemaRef ds:uri="http://schemas.openxmlformats.org/package/2006/metadata/core-properties"/>
+    <ds:schemaRef ds:uri="http://purl.org/dc/elements/1.1/"/>
+    <ds:schemaRef ds:uri="http://purl.org/dc/terms/"/>
+    <ds:schemaRef ds:uri="http://schemas.microsoft.com/internal/obd"/>
   </ds:schemaRefs>
 </ds:datastoreItem>
 </file>
</xml_diff>